<commit_message>
Atualizando texto sobre MCMEG na pag sobre
</commit_message>
<xml_diff>
--- a/Apresentação1.pptx
+++ b/Apresentação1.pptx
@@ -8,8 +8,9 @@
     <p:sldId id="256" r:id="rId2"/>
     <p:sldId id="257" r:id="rId3"/>
     <p:sldId id="260" r:id="rId4"/>
-    <p:sldId id="258" r:id="rId5"/>
-    <p:sldId id="259" r:id="rId6"/>
+    <p:sldId id="261" r:id="rId5"/>
+    <p:sldId id="258" r:id="rId6"/>
+    <p:sldId id="259" r:id="rId7"/>
   </p:sldIdLst>
   <p:sldSz cx="12192000" cy="6858000"/>
   <p:notesSz cx="6858000" cy="9144000"/>
@@ -11221,6 +11222,96 @@
           <a:chExt cx="0" cy="0"/>
         </a:xfrm>
       </p:grpSpPr>
+      <p:pic>
+        <p:nvPicPr>
+          <p:cNvPr id="5" name="Imagem 4">
+            <a:extLst>
+              <a:ext uri="{FF2B5EF4-FFF2-40B4-BE49-F238E27FC236}">
+                <a16:creationId xmlns:a16="http://schemas.microsoft.com/office/drawing/2014/main" id="{672BE874-6FA3-BEC5-3700-9B938B55F9A8}"/>
+              </a:ext>
+            </a:extLst>
+          </p:cNvPr>
+          <p:cNvPicPr>
+            <a:picLocks noChangeAspect="1"/>
+          </p:cNvPicPr>
+          <p:nvPr/>
+        </p:nvPicPr>
+        <p:blipFill>
+          <a:blip r:embed="rId2"/>
+          <a:stretch>
+            <a:fillRect/>
+          </a:stretch>
+        </p:blipFill>
+        <p:spPr>
+          <a:xfrm>
+            <a:off x="1102611" y="936135"/>
+            <a:ext cx="9693480" cy="4381880"/>
+          </a:xfrm>
+          <a:prstGeom prst="rect">
+            <a:avLst/>
+          </a:prstGeom>
+        </p:spPr>
+      </p:pic>
+      <p:pic>
+        <p:nvPicPr>
+          <p:cNvPr id="7" name="Imagem 6">
+            <a:extLst>
+              <a:ext uri="{FF2B5EF4-FFF2-40B4-BE49-F238E27FC236}">
+                <a16:creationId xmlns:a16="http://schemas.microsoft.com/office/drawing/2014/main" id="{F1A43ABB-DF1B-01BC-505B-0C8D0804EBF3}"/>
+              </a:ext>
+            </a:extLst>
+          </p:cNvPr>
+          <p:cNvPicPr>
+            <a:picLocks noChangeAspect="1"/>
+          </p:cNvPicPr>
+          <p:nvPr/>
+        </p:nvPicPr>
+        <p:blipFill>
+          <a:blip r:embed="rId3"/>
+          <a:stretch>
+            <a:fillRect/>
+          </a:stretch>
+        </p:blipFill>
+        <p:spPr>
+          <a:xfrm>
+            <a:off x="7019387" y="936135"/>
+            <a:ext cx="2245383" cy="637098"/>
+          </a:xfrm>
+          <a:prstGeom prst="rect">
+            <a:avLst/>
+          </a:prstGeom>
+        </p:spPr>
+      </p:pic>
+    </p:spTree>
+    <p:extLst>
+      <p:ext uri="{BB962C8B-B14F-4D97-AF65-F5344CB8AC3E}">
+        <p14:creationId xmlns:p14="http://schemas.microsoft.com/office/powerpoint/2010/main" val="3549739208"/>
+      </p:ext>
+    </p:extLst>
+  </p:cSld>
+  <p:clrMapOvr>
+    <a:masterClrMapping/>
+  </p:clrMapOvr>
+</p:sld>
+</file>
+
+<file path=ppt/slides/slide5.xml><?xml version="1.0" encoding="utf-8"?>
+<p:sld xmlns:a="http://schemas.openxmlformats.org/drawingml/2006/main" xmlns:r="http://schemas.openxmlformats.org/officeDocument/2006/relationships" xmlns:p="http://schemas.openxmlformats.org/presentationml/2006/main">
+  <p:cSld>
+    <p:spTree>
+      <p:nvGrpSpPr>
+        <p:cNvPr id="1" name=""/>
+        <p:cNvGrpSpPr/>
+        <p:nvPr/>
+      </p:nvGrpSpPr>
+      <p:grpSpPr>
+        <a:xfrm>
+          <a:off x="0" y="0"/>
+          <a:ext cx="0" cy="0"/>
+          <a:chOff x="0" y="0"/>
+          <a:chExt cx="0" cy="0"/>
+        </a:xfrm>
+      </p:grpSpPr>
       <p:sp>
         <p:nvSpPr>
           <p:cNvPr id="10" name="Retângulo 9">
@@ -11384,7 +11475,7 @@
 </p:sld>
 </file>
 
-<file path=ppt/slides/slide5.xml><?xml version="1.0" encoding="utf-8"?>
+<file path=ppt/slides/slide6.xml><?xml version="1.0" encoding="utf-8"?>
 <p:sld xmlns:a="http://schemas.openxmlformats.org/drawingml/2006/main" xmlns:r="http://schemas.openxmlformats.org/officeDocument/2006/relationships" xmlns:p="http://schemas.openxmlformats.org/presentationml/2006/main">
   <p:cSld>
     <p:spTree>

</xml_diff>